<commit_message>
feat: make AI payment policy activation fail closed
</commit_message>
<xml_diff>
--- a/docs/attestflow-pitch-deck.pptx
+++ b/docs/attestflow-pitch-deck.pptx
@@ -2,21 +2,21 @@
 <file path=ppt/presentation.xml><?xml version="1.0" encoding="utf-8"?>
 <p:presentation xmlns:p="http://schemas.openxmlformats.org/presentationml/2006/main">
   <p:sldMasterIdLst>
-    <p:sldMasterId xmlns:r="http://schemas.openxmlformats.org/officeDocument/2006/relationships" id="2147483648" r:id="R14df069c1b8840f9"/>
+    <p:sldMasterId xmlns:r="http://schemas.openxmlformats.org/officeDocument/2006/relationships" id="2147483648" r:id="R47a7254112214c04"/>
   </p:sldMasterIdLst>
   <p:notesMasterIdLst>
-    <p:notesMasterId xmlns:r="http://schemas.openxmlformats.org/officeDocument/2006/relationships" r:id="R05523acab65448ac"/>
+    <p:notesMasterId xmlns:r="http://schemas.openxmlformats.org/officeDocument/2006/relationships" r:id="R3e75bba8eecd4dad"/>
   </p:notesMasterIdLst>
   <p:sldIdLst>
-    <p:sldId xmlns:r="http://schemas.openxmlformats.org/officeDocument/2006/relationships" id="256" r:id="R990b9a99f72a43b9"/>
-    <p:sldId xmlns:r="http://schemas.openxmlformats.org/officeDocument/2006/relationships" id="257" r:id="R8830897711b745d6"/>
-    <p:sldId xmlns:r="http://schemas.openxmlformats.org/officeDocument/2006/relationships" id="258" r:id="Rf8c179d9d10c43d2"/>
-    <p:sldId xmlns:r="http://schemas.openxmlformats.org/officeDocument/2006/relationships" id="259" r:id="R974a50debe434350"/>
-    <p:sldId xmlns:r="http://schemas.openxmlformats.org/officeDocument/2006/relationships" id="260" r:id="R943586829bb04811"/>
-    <p:sldId xmlns:r="http://schemas.openxmlformats.org/officeDocument/2006/relationships" id="261" r:id="R4720b09b6ec948a3"/>
-    <p:sldId xmlns:r="http://schemas.openxmlformats.org/officeDocument/2006/relationships" id="262" r:id="Re9e6132f070041e3"/>
-    <p:sldId xmlns:r="http://schemas.openxmlformats.org/officeDocument/2006/relationships" id="263" r:id="R836f4768ec4641ec"/>
-    <p:sldId xmlns:r="http://schemas.openxmlformats.org/officeDocument/2006/relationships" id="264" r:id="R38a881dd55794e61"/>
+    <p:sldId xmlns:r="http://schemas.openxmlformats.org/officeDocument/2006/relationships" id="256" r:id="R029b4d68ba164010"/>
+    <p:sldId xmlns:r="http://schemas.openxmlformats.org/officeDocument/2006/relationships" id="257" r:id="R7dad2c87e71a4d57"/>
+    <p:sldId xmlns:r="http://schemas.openxmlformats.org/officeDocument/2006/relationships" id="258" r:id="Rdcca87b9592b4075"/>
+    <p:sldId xmlns:r="http://schemas.openxmlformats.org/officeDocument/2006/relationships" id="259" r:id="R81e78e2656964fd5"/>
+    <p:sldId xmlns:r="http://schemas.openxmlformats.org/officeDocument/2006/relationships" id="260" r:id="Ra17b4aa07f0e4490"/>
+    <p:sldId xmlns:r="http://schemas.openxmlformats.org/officeDocument/2006/relationships" id="261" r:id="R19df5d916fae4f07"/>
+    <p:sldId xmlns:r="http://schemas.openxmlformats.org/officeDocument/2006/relationships" id="262" r:id="R2ad301a739a94004"/>
+    <p:sldId xmlns:r="http://schemas.openxmlformats.org/officeDocument/2006/relationships" id="263" r:id="Rcbe4ea578d73465f"/>
+    <p:sldId xmlns:r="http://schemas.openxmlformats.org/officeDocument/2006/relationships" id="264" r:id="Rc0be3db09b5c4d2b"/>
   </p:sldIdLst>
   <p:sldSz cx="12192000" cy="6858000"/>
   <p:notesSz cx="6858000" cy="9144000"/>
@@ -1233,7 +1233,7 @@
   </p:cSld>
   <p:clrMap bg1="lt1" tx1="dk1" bg2="lt2" tx2="dk2" accent1="accent1" accent2="accent2" accent3="accent3" accent4="accent4" accent5="accent5" accent6="accent6" hlink="hlink" folHlink="folHlink"/>
   <p:sldLayoutIdLst>
-    <p:sldLayoutId xmlns:r="http://schemas.openxmlformats.org/officeDocument/2006/relationships" id="2147483649" r:id="R86dd41de62bb4fa7"/>
+    <p:sldLayoutId xmlns:r="http://schemas.openxmlformats.org/officeDocument/2006/relationships" id="2147483649" r:id="R22ef7e7846cb44dd"/>
   </p:sldLayoutIdLst>
   <p:txStyles>
     <p:titleStyle>
@@ -1814,6 +1814,7 @@
           <a:lstStyle xmlns:a="http://schemas.openxmlformats.org/drawingml/2006/main"/>
           <a:p xmlns:a="http://schemas.openxmlformats.org/drawingml/2006/main">
             <a:pPr algn="l">
+              <a:buNone/>
               <a:defRPr sz="1050" b="1">
                 <a:solidFill>
                   <a:srgbClr val="087A58"/>
@@ -1872,6 +1873,7 @@
           <a:lstStyle xmlns:a="http://schemas.openxmlformats.org/drawingml/2006/main"/>
           <a:p xmlns:a="http://schemas.openxmlformats.org/drawingml/2006/main">
             <a:pPr algn="l">
+              <a:buNone/>
               <a:defRPr sz="5400" b="1">
                 <a:solidFill>
                   <a:srgbClr val="08110E"/>
@@ -1930,6 +1932,7 @@
           <a:lstStyle xmlns:a="http://schemas.openxmlformats.org/drawingml/2006/main"/>
           <a:p xmlns:a="http://schemas.openxmlformats.org/drawingml/2006/main">
             <a:pPr algn="l">
+              <a:buNone/>
               <a:defRPr sz="2325" b="1">
                 <a:solidFill>
                   <a:srgbClr val="064B39"/>
@@ -2019,6 +2022,7 @@
           <a:lstStyle xmlns:a="http://schemas.openxmlformats.org/drawingml/2006/main"/>
           <a:p xmlns:a="http://schemas.openxmlformats.org/drawingml/2006/main">
             <a:pPr algn="l">
+              <a:buNone/>
               <a:defRPr sz="1725" b="0">
                 <a:solidFill>
                   <a:srgbClr val="5C6863"/>
@@ -2042,6 +2046,7 @@
           </a:p>
           <a:p xmlns:a="http://schemas.openxmlformats.org/drawingml/2006/main">
             <a:pPr algn="l">
+              <a:buNone/>
               <a:defRPr sz="1725" b="0">
                 <a:solidFill>
                   <a:srgbClr val="5C6863"/>
@@ -2065,6 +2070,7 @@
           </a:p>
           <a:p xmlns:a="http://schemas.openxmlformats.org/drawingml/2006/main">
             <a:pPr algn="l">
+              <a:buNone/>
               <a:defRPr sz="1725" b="0">
                 <a:solidFill>
                   <a:srgbClr val="5C6863"/>
@@ -2123,6 +2129,7 @@
           <a:lstStyle xmlns:a="http://schemas.openxmlformats.org/drawingml/2006/main"/>
           <a:p xmlns:a="http://schemas.openxmlformats.org/drawingml/2006/main">
             <a:pPr algn="l">
+              <a:buNone/>
               <a:defRPr sz="1200" b="1">
                 <a:solidFill>
                   <a:srgbClr val="08110E"/>
@@ -2141,7 +2148,29 @@
                 <a:ea typeface="Helvetica Neue"/>
                 <a:cs typeface="Helvetica Neue"/>
               </a:rPr>
-              <a:t>3 linked public-testnet transactions  ·  62 live checks  ·  28 automated tests</a:t>
+              <a:t>3 linked public-testnet transactions  ·  62 live checks  ·  </a:t>
+            </a:r>
+            <a:r>
+              <a:rPr sz="1200" b="1">
+                <a:solidFill>
+                  <a:srgbClr val="08110E"/>
+                </a:solidFill>
+                <a:latin typeface="Helvetica Neue"/>
+                <a:ea typeface="Helvetica Neue"/>
+                <a:cs typeface="Helvetica Neue"/>
+              </a:rPr>
+              <a:t>32</a:t>
+            </a:r>
+            <a:r>
+              <a:rPr sz="1200" b="1">
+                <a:solidFill>
+                  <a:srgbClr val="08110E"/>
+                </a:solidFill>
+                <a:latin typeface="Helvetica Neue"/>
+                <a:ea typeface="Helvetica Neue"/>
+                <a:cs typeface="Helvetica Neue"/>
+              </a:rPr>
+              <a:t> automated tests</a:t>
             </a:r>
           </a:p>
         </p:txBody>
@@ -2183,14 +2212,14 @@
       </p:sp>
       <p:pic>
         <p:nvPicPr>
-          <p:cNvPr id="18" name=""/>
+          <p:cNvPr id="20" name=""/>
           <p:cNvPicPr>
             <a:picLocks xmlns:a="http://schemas.openxmlformats.org/drawingml/2006/main" noChangeAspect="1"/>
           </p:cNvPicPr>
           <p:nvPr/>
         </p:nvPicPr>
         <p:blipFill>
-          <a:blip xmlns:r="http://schemas.openxmlformats.org/officeDocument/2006/relationships" xmlns:a="http://schemas.openxmlformats.org/drawingml/2006/main" r:embed="R8313bb92071040e4"/>
+          <a:blip xmlns:r="http://schemas.openxmlformats.org/officeDocument/2006/relationships" xmlns:a="http://schemas.openxmlformats.org/drawingml/2006/main" r:embed="R7b2683bb15cf44da"/>
           <a:srcRect xmlns:a="http://schemas.openxmlformats.org/drawingml/2006/main" l="20871" t="0" r="20871" b="0"/>
           <a:stretch xmlns:a="http://schemas.openxmlformats.org/drawingml/2006/main">
             <a:fillRect l="0" t="0" r="0" b="0"/>
@@ -2274,6 +2303,7 @@
           <a:lstStyle xmlns:a="http://schemas.openxmlformats.org/drawingml/2006/main"/>
           <a:p xmlns:a="http://schemas.openxmlformats.org/drawingml/2006/main">
             <a:pPr algn="l">
+              <a:buNone/>
               <a:defRPr sz="975" b="1">
                 <a:solidFill>
                   <a:srgbClr val="5C6863"/>
@@ -2361,6 +2391,7 @@
           <a:lstStyle xmlns:a="http://schemas.openxmlformats.org/drawingml/2006/main"/>
           <a:p xmlns:a="http://schemas.openxmlformats.org/drawingml/2006/main">
             <a:pPr algn="l">
+              <a:buNone/>
               <a:defRPr sz="1050" b="1">
                 <a:solidFill>
                   <a:srgbClr val="087A58"/>
@@ -2419,6 +2450,7 @@
           <a:lstStyle xmlns:a="http://schemas.openxmlformats.org/drawingml/2006/main"/>
           <a:p xmlns:a="http://schemas.openxmlformats.org/drawingml/2006/main">
             <a:pPr algn="l">
+              <a:buNone/>
               <a:defRPr sz="3150" b="1">
                 <a:solidFill>
                   <a:srgbClr val="08110E"/>
@@ -2477,6 +2509,7 @@
           <a:lstStyle xmlns:a="http://schemas.openxmlformats.org/drawingml/2006/main"/>
           <a:p xmlns:a="http://schemas.openxmlformats.org/drawingml/2006/main">
             <a:pPr algn="l">
+              <a:buNone/>
               <a:defRPr sz="2475" b="1">
                 <a:solidFill>
                   <a:srgbClr val="08110E"/>
@@ -2500,6 +2533,7 @@
           </a:p>
           <a:p xmlns:a="http://schemas.openxmlformats.org/drawingml/2006/main">
             <a:pPr algn="l">
+              <a:buNone/>
               <a:defRPr sz="2475" b="1">
                 <a:solidFill>
                   <a:srgbClr val="08110E"/>
@@ -2589,6 +2623,7 @@
           <a:lstStyle xmlns:a="http://schemas.openxmlformats.org/drawingml/2006/main"/>
           <a:p xmlns:a="http://schemas.openxmlformats.org/drawingml/2006/main">
             <a:pPr algn="l">
+              <a:buNone/>
               <a:defRPr sz="1575" b="0">
                 <a:solidFill>
                   <a:srgbClr val="064B39"/>
@@ -2678,6 +2713,7 @@
           <a:lstStyle xmlns:a="http://schemas.openxmlformats.org/drawingml/2006/main"/>
           <a:p xmlns:a="http://schemas.openxmlformats.org/drawingml/2006/main">
             <a:pPr algn="l">
+              <a:buNone/>
               <a:defRPr sz="1275" b="1">
                 <a:solidFill>
                   <a:srgbClr val="087A58"/>
@@ -2736,6 +2772,7 @@
           <a:lstStyle xmlns:a="http://schemas.openxmlformats.org/drawingml/2006/main"/>
           <a:p xmlns:a="http://schemas.openxmlformats.org/drawingml/2006/main">
             <a:pPr algn="l">
+              <a:buNone/>
               <a:defRPr sz="1800" b="1">
                 <a:solidFill>
                   <a:srgbClr val="08110E"/>
@@ -2794,6 +2831,7 @@
           <a:lstStyle xmlns:a="http://schemas.openxmlformats.org/drawingml/2006/main"/>
           <a:p xmlns:a="http://schemas.openxmlformats.org/drawingml/2006/main">
             <a:pPr algn="l">
+              <a:buNone/>
               <a:defRPr sz="1275" b="0">
                 <a:solidFill>
                   <a:srgbClr val="5C6863"/>
@@ -2852,6 +2890,7 @@
           <a:lstStyle xmlns:a="http://schemas.openxmlformats.org/drawingml/2006/main"/>
           <a:p xmlns:a="http://schemas.openxmlformats.org/drawingml/2006/main">
             <a:pPr algn="l">
+              <a:buNone/>
               <a:defRPr sz="1275" b="1">
                 <a:solidFill>
                   <a:srgbClr val="087A58"/>
@@ -2910,6 +2949,7 @@
           <a:lstStyle xmlns:a="http://schemas.openxmlformats.org/drawingml/2006/main"/>
           <a:p xmlns:a="http://schemas.openxmlformats.org/drawingml/2006/main">
             <a:pPr algn="l">
+              <a:buNone/>
               <a:defRPr sz="1800" b="1">
                 <a:solidFill>
                   <a:srgbClr val="08110E"/>
@@ -2968,6 +3008,7 @@
           <a:lstStyle xmlns:a="http://schemas.openxmlformats.org/drawingml/2006/main"/>
           <a:p xmlns:a="http://schemas.openxmlformats.org/drawingml/2006/main">
             <a:pPr algn="l">
+              <a:buNone/>
               <a:defRPr sz="1275" b="0">
                 <a:solidFill>
                   <a:srgbClr val="5C6863"/>
@@ -3026,6 +3067,7 @@
           <a:lstStyle xmlns:a="http://schemas.openxmlformats.org/drawingml/2006/main"/>
           <a:p xmlns:a="http://schemas.openxmlformats.org/drawingml/2006/main">
             <a:pPr algn="l">
+              <a:buNone/>
               <a:defRPr sz="1275" b="1">
                 <a:solidFill>
                   <a:srgbClr val="087A58"/>
@@ -3084,6 +3126,7 @@
           <a:lstStyle xmlns:a="http://schemas.openxmlformats.org/drawingml/2006/main"/>
           <a:p xmlns:a="http://schemas.openxmlformats.org/drawingml/2006/main">
             <a:pPr algn="l">
+              <a:buNone/>
               <a:defRPr sz="1800" b="1">
                 <a:solidFill>
                   <a:srgbClr val="08110E"/>
@@ -3142,6 +3185,7 @@
           <a:lstStyle xmlns:a="http://schemas.openxmlformats.org/drawingml/2006/main"/>
           <a:p xmlns:a="http://schemas.openxmlformats.org/drawingml/2006/main">
             <a:pPr algn="l">
+              <a:buNone/>
               <a:defRPr sz="1275" b="0">
                 <a:solidFill>
                   <a:srgbClr val="5C6863"/>
@@ -3231,6 +3275,7 @@
           <a:lstStyle xmlns:a="http://schemas.openxmlformats.org/drawingml/2006/main"/>
           <a:p xmlns:a="http://schemas.openxmlformats.org/drawingml/2006/main">
             <a:pPr algn="l">
+              <a:buNone/>
               <a:defRPr sz="975" b="1">
                 <a:solidFill>
                   <a:srgbClr val="5C6863"/>
@@ -3318,6 +3363,7 @@
           <a:lstStyle xmlns:a="http://schemas.openxmlformats.org/drawingml/2006/main"/>
           <a:p xmlns:a="http://schemas.openxmlformats.org/drawingml/2006/main">
             <a:pPr algn="l">
+              <a:buNone/>
               <a:defRPr sz="1050" b="1">
                 <a:solidFill>
                   <a:srgbClr val="087A58"/>
@@ -3376,6 +3422,7 @@
           <a:lstStyle xmlns:a="http://schemas.openxmlformats.org/drawingml/2006/main"/>
           <a:p xmlns:a="http://schemas.openxmlformats.org/drawingml/2006/main">
             <a:pPr algn="l">
+              <a:buNone/>
               <a:defRPr sz="3150" b="1">
                 <a:solidFill>
                   <a:srgbClr val="08110E"/>
@@ -3436,21 +3483,21 @@
       </p:sp>
       <p:pic>
         <p:nvPicPr>
-          <p:cNvPr id="28" name=""/>
+          <p:cNvPr id="30" name=""/>
           <p:cNvPicPr>
             <a:picLocks xmlns:a="http://schemas.openxmlformats.org/drawingml/2006/main" noChangeAspect="1"/>
           </p:cNvPicPr>
           <p:nvPr/>
         </p:nvPicPr>
         <p:blipFill>
-          <a:blip xmlns:r="http://schemas.openxmlformats.org/officeDocument/2006/relationships" xmlns:a="http://schemas.openxmlformats.org/drawingml/2006/main" r:embed="Rb642c1b8263e4ce1"/>
-          <a:srcRect xmlns:a="http://schemas.openxmlformats.org/drawingml/2006/main" l="2907" t="0" r="2907" b="0"/>
+          <a:blip xmlns:r="http://schemas.openxmlformats.org/officeDocument/2006/relationships" xmlns:a="http://schemas.openxmlformats.org/drawingml/2006/main" r:embed="R4d54f44556f6475d"/>
+          <a:srcRect xmlns:a="http://schemas.openxmlformats.org/drawingml/2006/main" l="0" t="0" r="0" b="0"/>
           <a:stretch xmlns:a="http://schemas.openxmlformats.org/drawingml/2006/main">
             <a:fillRect l="0" t="0" r="0" b="0"/>
           </a:stretch>
         </p:blipFill>
         <p:spPr>
-          <a:xfrm xmlns:a="http://schemas.openxmlformats.org/drawingml/2006/main">
+          <a:xfrm xmlns:a="http://schemas.openxmlformats.org/drawingml/2006/main" flipH="0" flipV="0">
             <a:off x="609600" y="1676400"/>
             <a:ext cx="6858000" cy="4095750"/>
           </a:xfrm>
@@ -3559,6 +3606,7 @@
           <a:lstStyle xmlns:a="http://schemas.openxmlformats.org/drawingml/2006/main"/>
           <a:p xmlns:a="http://schemas.openxmlformats.org/drawingml/2006/main">
             <a:pPr algn="ctr">
+              <a:buNone/>
               <a:defRPr sz="975" b="1">
                 <a:solidFill>
                   <a:srgbClr val="FFFFFF"/>
@@ -3617,6 +3665,7 @@
           <a:lstStyle xmlns:a="http://schemas.openxmlformats.org/drawingml/2006/main"/>
           <a:p xmlns:a="http://schemas.openxmlformats.org/drawingml/2006/main">
             <a:pPr algn="l">
+              <a:buNone/>
               <a:defRPr sz="1650" b="1">
                 <a:solidFill>
                   <a:srgbClr val="08110E"/>
@@ -3635,7 +3684,7 @@
                 <a:ea typeface="Helvetica Neue"/>
                 <a:cs typeface="Helvetica Neue"/>
               </a:rPr>
-              <a:t>Intent becomes policy</a:t>
+              <a:t>Intent becomes a draft</a:t>
             </a:r>
           </a:p>
         </p:txBody>
@@ -3675,6 +3724,7 @@
           <a:lstStyle xmlns:a="http://schemas.openxmlformats.org/drawingml/2006/main"/>
           <a:p xmlns:a="http://schemas.openxmlformats.org/drawingml/2006/main">
             <a:pPr algn="l">
+              <a:buNone/>
               <a:defRPr sz="1200" b="0">
                 <a:solidFill>
                   <a:srgbClr val="5C6863"/>
@@ -3693,7 +3743,7 @@
                 <a:ea typeface="Helvetica Neue"/>
                 <a:cs typeface="Helvetica Neue"/>
               </a:rPr>
-              <a:t>Exact amount, asset, payee, payout, beneficiary and destination.</a:t>
+              <a:t>Exact money fields stay inactive until explicit activation.</a:t>
             </a:r>
           </a:p>
         </p:txBody>
@@ -3768,6 +3818,7 @@
           <a:lstStyle xmlns:a="http://schemas.openxmlformats.org/drawingml/2006/main"/>
           <a:p xmlns:a="http://schemas.openxmlformats.org/drawingml/2006/main">
             <a:pPr algn="ctr">
+              <a:buNone/>
               <a:defRPr sz="975" b="1">
                 <a:solidFill>
                   <a:srgbClr val="FFFFFF"/>
@@ -3826,6 +3877,7 @@
           <a:lstStyle xmlns:a="http://schemas.openxmlformats.org/drawingml/2006/main"/>
           <a:p xmlns:a="http://schemas.openxmlformats.org/drawingml/2006/main">
             <a:pPr algn="l">
+              <a:buNone/>
               <a:defRPr sz="1650" b="1">
                 <a:solidFill>
                   <a:srgbClr val="08110E"/>
@@ -3884,6 +3936,7 @@
           <a:lstStyle xmlns:a="http://schemas.openxmlformats.org/drawingml/2006/main"/>
           <a:p xmlns:a="http://schemas.openxmlformats.org/drawingml/2006/main">
             <a:pPr algn="l">
+              <a:buNone/>
               <a:defRPr sz="1200" b="0">
                 <a:solidFill>
                   <a:srgbClr val="5C6863"/>
@@ -3977,6 +4030,7 @@
           <a:lstStyle xmlns:a="http://schemas.openxmlformats.org/drawingml/2006/main"/>
           <a:p xmlns:a="http://schemas.openxmlformats.org/drawingml/2006/main">
             <a:pPr algn="ctr">
+              <a:buNone/>
               <a:defRPr sz="975" b="1">
                 <a:solidFill>
                   <a:srgbClr val="FFFFFF"/>
@@ -4035,6 +4089,7 @@
           <a:lstStyle xmlns:a="http://schemas.openxmlformats.org/drawingml/2006/main"/>
           <a:p xmlns:a="http://schemas.openxmlformats.org/drawingml/2006/main">
             <a:pPr algn="l">
+              <a:buNone/>
               <a:defRPr sz="1650" b="1">
                 <a:solidFill>
                   <a:srgbClr val="08110E"/>
@@ -4093,6 +4148,7 @@
           <a:lstStyle xmlns:a="http://schemas.openxmlformats.org/drawingml/2006/main"/>
           <a:p xmlns:a="http://schemas.openxmlformats.org/drawingml/2006/main">
             <a:pPr algn="l">
+              <a:buNone/>
               <a:defRPr sz="1200" b="0">
                 <a:solidFill>
                   <a:srgbClr val="5C6863"/>
@@ -4186,6 +4242,7 @@
           <a:lstStyle xmlns:a="http://schemas.openxmlformats.org/drawingml/2006/main"/>
           <a:p xmlns:a="http://schemas.openxmlformats.org/drawingml/2006/main">
             <a:pPr algn="ctr">
+              <a:buNone/>
               <a:defRPr sz="975" b="1">
                 <a:solidFill>
                   <a:srgbClr val="FFFFFF"/>
@@ -4244,6 +4301,7 @@
           <a:lstStyle xmlns:a="http://schemas.openxmlformats.org/drawingml/2006/main"/>
           <a:p xmlns:a="http://schemas.openxmlformats.org/drawingml/2006/main">
             <a:pPr algn="l">
+              <a:buNone/>
               <a:defRPr sz="1650" b="1">
                 <a:solidFill>
                   <a:srgbClr val="08110E"/>
@@ -4302,6 +4360,7 @@
           <a:lstStyle xmlns:a="http://schemas.openxmlformats.org/drawingml/2006/main"/>
           <a:p xmlns:a="http://schemas.openxmlformats.org/drawingml/2006/main">
             <a:pPr algn="l">
+              <a:buNone/>
               <a:defRPr sz="1200" b="0">
                 <a:solidFill>
                   <a:srgbClr val="5C6863"/>
@@ -4360,6 +4419,7 @@
           <a:lstStyle xmlns:a="http://schemas.openxmlformats.org/drawingml/2006/main"/>
           <a:p xmlns:a="http://schemas.openxmlformats.org/drawingml/2006/main">
             <a:pPr algn="l">
+              <a:buNone/>
               <a:defRPr sz="1200" b="1">
                 <a:solidFill>
                   <a:srgbClr val="064B39"/>
@@ -4449,6 +4509,7 @@
           <a:lstStyle xmlns:a="http://schemas.openxmlformats.org/drawingml/2006/main"/>
           <a:p xmlns:a="http://schemas.openxmlformats.org/drawingml/2006/main">
             <a:pPr algn="l">
+              <a:buNone/>
               <a:defRPr sz="975" b="1">
                 <a:solidFill>
                   <a:srgbClr val="5C6863"/>
@@ -4536,6 +4597,7 @@
           <a:lstStyle xmlns:a="http://schemas.openxmlformats.org/drawingml/2006/main"/>
           <a:p xmlns:a="http://schemas.openxmlformats.org/drawingml/2006/main">
             <a:pPr algn="l">
+              <a:buNone/>
               <a:defRPr sz="1050" b="1">
                 <a:solidFill>
                   <a:srgbClr val="087A58"/>
@@ -4594,6 +4656,7 @@
           <a:lstStyle xmlns:a="http://schemas.openxmlformats.org/drawingml/2006/main"/>
           <a:p xmlns:a="http://schemas.openxmlformats.org/drawingml/2006/main">
             <a:pPr algn="l">
+              <a:buNone/>
               <a:defRPr sz="3150" b="1">
                 <a:solidFill>
                   <a:srgbClr val="08110E"/>
@@ -4654,14 +4717,14 @@
       </p:sp>
       <p:pic>
         <p:nvPicPr>
-          <p:cNvPr id="26" name=""/>
+          <p:cNvPr id="28" name=""/>
           <p:cNvPicPr>
             <a:picLocks xmlns:a="http://schemas.openxmlformats.org/drawingml/2006/main" noChangeAspect="1"/>
           </p:cNvPicPr>
           <p:nvPr/>
         </p:nvPicPr>
         <p:blipFill>
-          <a:blip xmlns:r="http://schemas.openxmlformats.org/officeDocument/2006/relationships" xmlns:a="http://schemas.openxmlformats.org/drawingml/2006/main" r:embed="R836b20c2dfcc4592"/>
+          <a:blip xmlns:r="http://schemas.openxmlformats.org/officeDocument/2006/relationships" xmlns:a="http://schemas.openxmlformats.org/drawingml/2006/main" r:embed="R5ca061f3864148c3"/>
           <a:srcRect xmlns:a="http://schemas.openxmlformats.org/drawingml/2006/main" l="9821" t="0" r="9821" b="0"/>
           <a:stretch xmlns:a="http://schemas.openxmlformats.org/drawingml/2006/main">
             <a:fillRect l="0" t="0" r="0" b="0"/>
@@ -4714,6 +4777,7 @@
           <a:lstStyle xmlns:a="http://schemas.openxmlformats.org/drawingml/2006/main"/>
           <a:p xmlns:a="http://schemas.openxmlformats.org/drawingml/2006/main">
             <a:pPr algn="l">
+              <a:buNone/>
               <a:defRPr sz="1125" b="1">
                 <a:solidFill>
                   <a:srgbClr val="087A58"/>
@@ -4772,6 +4836,7 @@
           <a:lstStyle xmlns:a="http://schemas.openxmlformats.org/drawingml/2006/main"/>
           <a:p xmlns:a="http://schemas.openxmlformats.org/drawingml/2006/main">
             <a:pPr algn="l">
+              <a:buNone/>
               <a:defRPr sz="1725" b="1">
                 <a:solidFill>
                   <a:srgbClr val="08110E"/>
@@ -4830,6 +4895,7 @@
           <a:lstStyle xmlns:a="http://schemas.openxmlformats.org/drawingml/2006/main"/>
           <a:p xmlns:a="http://schemas.openxmlformats.org/drawingml/2006/main">
             <a:pPr algn="l">
+              <a:buNone/>
               <a:defRPr sz="1200" b="0">
                 <a:solidFill>
                   <a:srgbClr val="5C6863"/>
@@ -4888,6 +4954,7 @@
           <a:lstStyle xmlns:a="http://schemas.openxmlformats.org/drawingml/2006/main"/>
           <a:p xmlns:a="http://schemas.openxmlformats.org/drawingml/2006/main">
             <a:pPr algn="l">
+              <a:buNone/>
               <a:defRPr sz="1125" b="1">
                 <a:solidFill>
                   <a:srgbClr val="087A58"/>
@@ -4946,6 +5013,7 @@
           <a:lstStyle xmlns:a="http://schemas.openxmlformats.org/drawingml/2006/main"/>
           <a:p xmlns:a="http://schemas.openxmlformats.org/drawingml/2006/main">
             <a:pPr algn="l">
+              <a:buNone/>
               <a:defRPr sz="1725" b="1">
                 <a:solidFill>
                   <a:srgbClr val="08110E"/>
@@ -5004,6 +5072,7 @@
           <a:lstStyle xmlns:a="http://schemas.openxmlformats.org/drawingml/2006/main"/>
           <a:p xmlns:a="http://schemas.openxmlformats.org/drawingml/2006/main">
             <a:pPr algn="l">
+              <a:buNone/>
               <a:defRPr sz="1200" b="0">
                 <a:solidFill>
                   <a:srgbClr val="5C6863"/>
@@ -5062,6 +5131,7 @@
           <a:lstStyle xmlns:a="http://schemas.openxmlformats.org/drawingml/2006/main"/>
           <a:p xmlns:a="http://schemas.openxmlformats.org/drawingml/2006/main">
             <a:pPr algn="l">
+              <a:buNone/>
               <a:defRPr sz="1125" b="1">
                 <a:solidFill>
                   <a:srgbClr val="087A58"/>
@@ -5120,6 +5190,7 @@
           <a:lstStyle xmlns:a="http://schemas.openxmlformats.org/drawingml/2006/main"/>
           <a:p xmlns:a="http://schemas.openxmlformats.org/drawingml/2006/main">
             <a:pPr algn="l">
+              <a:buNone/>
               <a:defRPr sz="1725" b="1">
                 <a:solidFill>
                   <a:srgbClr val="08110E"/>
@@ -5178,6 +5249,7 @@
           <a:lstStyle xmlns:a="http://schemas.openxmlformats.org/drawingml/2006/main"/>
           <a:p xmlns:a="http://schemas.openxmlformats.org/drawingml/2006/main">
             <a:pPr algn="l">
+              <a:buNone/>
               <a:defRPr sz="1200" b="0">
                 <a:solidFill>
                   <a:srgbClr val="5C6863"/>
@@ -5236,6 +5308,7 @@
           <a:lstStyle xmlns:a="http://schemas.openxmlformats.org/drawingml/2006/main"/>
           <a:p xmlns:a="http://schemas.openxmlformats.org/drawingml/2006/main">
             <a:pPr algn="l">
+              <a:buNone/>
               <a:defRPr sz="1125" b="1">
                 <a:solidFill>
                   <a:srgbClr val="087A58"/>
@@ -5294,6 +5367,7 @@
           <a:lstStyle xmlns:a="http://schemas.openxmlformats.org/drawingml/2006/main"/>
           <a:p xmlns:a="http://schemas.openxmlformats.org/drawingml/2006/main">
             <a:pPr algn="l">
+              <a:buNone/>
               <a:defRPr sz="1725" b="1">
                 <a:solidFill>
                   <a:srgbClr val="08110E"/>
@@ -5352,6 +5426,7 @@
           <a:lstStyle xmlns:a="http://schemas.openxmlformats.org/drawingml/2006/main"/>
           <a:p xmlns:a="http://schemas.openxmlformats.org/drawingml/2006/main">
             <a:pPr algn="l">
+              <a:buNone/>
               <a:defRPr sz="1200" b="0">
                 <a:solidFill>
                   <a:srgbClr val="5C6863"/>
@@ -5410,6 +5485,7 @@
           <a:lstStyle xmlns:a="http://schemas.openxmlformats.org/drawingml/2006/main"/>
           <a:p xmlns:a="http://schemas.openxmlformats.org/drawingml/2006/main">
             <a:pPr algn="l">
+              <a:buNone/>
               <a:defRPr sz="1125" b="1">
                 <a:solidFill>
                   <a:srgbClr val="087A58"/>
@@ -5468,6 +5544,7 @@
           <a:lstStyle xmlns:a="http://schemas.openxmlformats.org/drawingml/2006/main"/>
           <a:p xmlns:a="http://schemas.openxmlformats.org/drawingml/2006/main">
             <a:pPr algn="l">
+              <a:buNone/>
               <a:defRPr sz="1725" b="1">
                 <a:solidFill>
                   <a:srgbClr val="08110E"/>
@@ -5526,6 +5603,7 @@
           <a:lstStyle xmlns:a="http://schemas.openxmlformats.org/drawingml/2006/main"/>
           <a:p xmlns:a="http://schemas.openxmlformats.org/drawingml/2006/main">
             <a:pPr algn="l">
+              <a:buNone/>
               <a:defRPr sz="1200" b="0">
                 <a:solidFill>
                   <a:srgbClr val="5C6863"/>
@@ -5584,6 +5662,7 @@
           <a:lstStyle xmlns:a="http://schemas.openxmlformats.org/drawingml/2006/main"/>
           <a:p xmlns:a="http://schemas.openxmlformats.org/drawingml/2006/main">
             <a:pPr algn="l">
+              <a:buNone/>
               <a:defRPr sz="1125" b="1">
                 <a:solidFill>
                   <a:srgbClr val="064B39"/>
@@ -5673,6 +5752,7 @@
           <a:lstStyle xmlns:a="http://schemas.openxmlformats.org/drawingml/2006/main"/>
           <a:p xmlns:a="http://schemas.openxmlformats.org/drawingml/2006/main">
             <a:pPr algn="l">
+              <a:buNone/>
               <a:defRPr sz="975" b="1">
                 <a:solidFill>
                   <a:srgbClr val="5C6863"/>
@@ -5760,6 +5840,7 @@
           <a:lstStyle xmlns:a="http://schemas.openxmlformats.org/drawingml/2006/main"/>
           <a:p xmlns:a="http://schemas.openxmlformats.org/drawingml/2006/main">
             <a:pPr algn="l">
+              <a:buNone/>
               <a:defRPr sz="1050" b="1">
                 <a:solidFill>
                   <a:srgbClr val="087A58"/>
@@ -5818,6 +5899,7 @@
           <a:lstStyle xmlns:a="http://schemas.openxmlformats.org/drawingml/2006/main"/>
           <a:p xmlns:a="http://schemas.openxmlformats.org/drawingml/2006/main">
             <a:pPr algn="l">
+              <a:buNone/>
               <a:defRPr sz="3150" b="1">
                 <a:solidFill>
                   <a:srgbClr val="08110E"/>
@@ -5878,14 +5960,14 @@
       </p:sp>
       <p:pic>
         <p:nvPicPr>
-          <p:cNvPr id="25" name=""/>
+          <p:cNvPr id="27" name=""/>
           <p:cNvPicPr>
             <a:picLocks xmlns:a="http://schemas.openxmlformats.org/drawingml/2006/main" noChangeAspect="1"/>
           </p:cNvPicPr>
           <p:nvPr/>
         </p:nvPicPr>
         <p:blipFill>
-          <a:blip xmlns:r="http://schemas.openxmlformats.org/officeDocument/2006/relationships" xmlns:a="http://schemas.openxmlformats.org/drawingml/2006/main" r:embed="Rc8f73f6ac39746de"/>
+          <a:blip xmlns:r="http://schemas.openxmlformats.org/officeDocument/2006/relationships" xmlns:a="http://schemas.openxmlformats.org/drawingml/2006/main" r:embed="R19fa335a71a74281"/>
           <a:srcRect xmlns:a="http://schemas.openxmlformats.org/drawingml/2006/main" l="7485" t="0" r="7485" b="0"/>
           <a:stretch xmlns:a="http://schemas.openxmlformats.org/drawingml/2006/main">
             <a:fillRect l="0" t="0" r="0" b="0"/>
@@ -5969,6 +6051,7 @@
           <a:lstStyle xmlns:a="http://schemas.openxmlformats.org/drawingml/2006/main"/>
           <a:p xmlns:a="http://schemas.openxmlformats.org/drawingml/2006/main">
             <a:pPr algn="l">
+              <a:buNone/>
               <a:defRPr sz="1050" b="1">
                 <a:solidFill>
                   <a:srgbClr val="5C6863"/>
@@ -6027,6 +6110,7 @@
           <a:lstStyle xmlns:a="http://schemas.openxmlformats.org/drawingml/2006/main"/>
           <a:p xmlns:a="http://schemas.openxmlformats.org/drawingml/2006/main">
             <a:pPr algn="l">
+              <a:buNone/>
               <a:defRPr sz="1650" b="1">
                 <a:solidFill>
                   <a:srgbClr val="08110E"/>
@@ -6085,6 +6169,7 @@
           <a:lstStyle xmlns:a="http://schemas.openxmlformats.org/drawingml/2006/main"/>
           <a:p xmlns:a="http://schemas.openxmlformats.org/drawingml/2006/main">
             <a:pPr algn="l">
+              <a:buNone/>
               <a:defRPr sz="1050" b="1">
                 <a:solidFill>
                   <a:srgbClr val="087A58"/>
@@ -6178,6 +6263,7 @@
           <a:lstStyle xmlns:a="http://schemas.openxmlformats.org/drawingml/2006/main"/>
           <a:p xmlns:a="http://schemas.openxmlformats.org/drawingml/2006/main">
             <a:pPr algn="l">
+              <a:buNone/>
               <a:defRPr sz="1350" b="1">
                 <a:solidFill>
                   <a:srgbClr val="08110E"/>
@@ -6271,6 +6357,7 @@
           <a:lstStyle xmlns:a="http://schemas.openxmlformats.org/drawingml/2006/main"/>
           <a:p xmlns:a="http://schemas.openxmlformats.org/drawingml/2006/main">
             <a:pPr algn="l">
+              <a:buNone/>
               <a:defRPr sz="1350" b="1">
                 <a:solidFill>
                   <a:srgbClr val="08110E"/>
@@ -6364,6 +6451,7 @@
           <a:lstStyle xmlns:a="http://schemas.openxmlformats.org/drawingml/2006/main"/>
           <a:p xmlns:a="http://schemas.openxmlformats.org/drawingml/2006/main">
             <a:pPr algn="l">
+              <a:buNone/>
               <a:defRPr sz="1350" b="0">
                 <a:solidFill>
                   <a:srgbClr val="08110E"/>
@@ -6457,6 +6545,7 @@
           <a:lstStyle xmlns:a="http://schemas.openxmlformats.org/drawingml/2006/main"/>
           <a:p xmlns:a="http://schemas.openxmlformats.org/drawingml/2006/main">
             <a:pPr algn="l">
+              <a:buNone/>
               <a:defRPr sz="1350" b="0">
                 <a:solidFill>
                   <a:srgbClr val="08110E"/>
@@ -6550,6 +6639,7 @@
           <a:lstStyle xmlns:a="http://schemas.openxmlformats.org/drawingml/2006/main"/>
           <a:p xmlns:a="http://schemas.openxmlformats.org/drawingml/2006/main">
             <a:pPr algn="l">
+              <a:buNone/>
               <a:defRPr sz="1350" b="0">
                 <a:solidFill>
                   <a:srgbClr val="08110E"/>
@@ -6608,6 +6698,7 @@
           <a:lstStyle xmlns:a="http://schemas.openxmlformats.org/drawingml/2006/main"/>
           <a:p xmlns:a="http://schemas.openxmlformats.org/drawingml/2006/main">
             <a:pPr algn="l">
+              <a:buNone/>
               <a:defRPr sz="1275" b="1">
                 <a:solidFill>
                   <a:srgbClr val="064B39"/>
@@ -6697,6 +6788,7 @@
           <a:lstStyle xmlns:a="http://schemas.openxmlformats.org/drawingml/2006/main"/>
           <a:p xmlns:a="http://schemas.openxmlformats.org/drawingml/2006/main">
             <a:pPr algn="l">
+              <a:buNone/>
               <a:defRPr sz="975" b="1">
                 <a:solidFill>
                   <a:srgbClr val="5C6863"/>
@@ -6784,6 +6876,7 @@
           <a:lstStyle xmlns:a="http://schemas.openxmlformats.org/drawingml/2006/main"/>
           <a:p xmlns:a="http://schemas.openxmlformats.org/drawingml/2006/main">
             <a:pPr algn="l">
+              <a:buNone/>
               <a:defRPr sz="1050" b="1">
                 <a:solidFill>
                   <a:srgbClr val="087A58"/>
@@ -6842,6 +6935,7 @@
           <a:lstStyle xmlns:a="http://schemas.openxmlformats.org/drawingml/2006/main"/>
           <a:p xmlns:a="http://schemas.openxmlformats.org/drawingml/2006/main">
             <a:pPr algn="l">
+              <a:buNone/>
               <a:defRPr sz="3150" b="1">
                 <a:solidFill>
                   <a:srgbClr val="08110E"/>
@@ -6900,6 +6994,7 @@
           <a:lstStyle xmlns:a="http://schemas.openxmlformats.org/drawingml/2006/main"/>
           <a:p xmlns:a="http://schemas.openxmlformats.org/drawingml/2006/main">
             <a:pPr algn="l">
+              <a:buNone/>
               <a:defRPr sz="1500" b="0">
                 <a:solidFill>
                   <a:srgbClr val="5C6863"/>
@@ -7024,6 +7119,7 @@
           <a:lstStyle xmlns:a="http://schemas.openxmlformats.org/drawingml/2006/main"/>
           <a:p xmlns:a="http://schemas.openxmlformats.org/drawingml/2006/main">
             <a:pPr algn="ctr">
+              <a:buNone/>
               <a:defRPr sz="975" b="1">
                 <a:solidFill>
                   <a:srgbClr val="FFFFFF"/>
@@ -7082,6 +7178,7 @@
           <a:lstStyle xmlns:a="http://schemas.openxmlformats.org/drawingml/2006/main"/>
           <a:p xmlns:a="http://schemas.openxmlformats.org/drawingml/2006/main">
             <a:pPr algn="l">
+              <a:buNone/>
               <a:defRPr sz="1050" b="1">
                 <a:solidFill>
                   <a:srgbClr val="087A58"/>
@@ -7140,6 +7237,7 @@
           <a:lstStyle xmlns:a="http://schemas.openxmlformats.org/drawingml/2006/main"/>
           <a:p xmlns:a="http://schemas.openxmlformats.org/drawingml/2006/main">
             <a:pPr algn="l">
+              <a:buNone/>
               <a:defRPr sz="1875" b="1">
                 <a:solidFill>
                   <a:srgbClr val="08110E"/>
@@ -7198,6 +7296,7 @@
           <a:lstStyle xmlns:a="http://schemas.openxmlformats.org/drawingml/2006/main"/>
           <a:p xmlns:a="http://schemas.openxmlformats.org/drawingml/2006/main">
             <a:pPr algn="l">
+              <a:buNone/>
               <a:defRPr sz="1275" b="0">
                 <a:solidFill>
                   <a:srgbClr val="5C6863"/>
@@ -7221,6 +7320,7 @@
           </a:p>
           <a:p xmlns:a="http://schemas.openxmlformats.org/drawingml/2006/main">
             <a:pPr algn="l">
+              <a:buNone/>
               <a:defRPr sz="1275" b="0">
                 <a:solidFill>
                   <a:srgbClr val="5C6863"/>
@@ -7244,6 +7344,7 @@
           </a:p>
           <a:p xmlns:a="http://schemas.openxmlformats.org/drawingml/2006/main">
             <a:pPr algn="l">
+              <a:buNone/>
               <a:defRPr sz="1275" b="0">
                 <a:solidFill>
                   <a:srgbClr val="5C6863"/>
@@ -7267,6 +7368,7 @@
           </a:p>
           <a:p xmlns:a="http://schemas.openxmlformats.org/drawingml/2006/main">
             <a:pPr algn="l">
+              <a:buNone/>
               <a:defRPr sz="1275" b="0">
                 <a:solidFill>
                   <a:srgbClr val="5C6863"/>
@@ -7360,6 +7462,7 @@
           <a:lstStyle xmlns:a="http://schemas.openxmlformats.org/drawingml/2006/main"/>
           <a:p xmlns:a="http://schemas.openxmlformats.org/drawingml/2006/main">
             <a:pPr algn="ctr">
+              <a:buNone/>
               <a:defRPr sz="975" b="1">
                 <a:solidFill>
                   <a:srgbClr val="FFFFFF"/>
@@ -7418,6 +7521,7 @@
           <a:lstStyle xmlns:a="http://schemas.openxmlformats.org/drawingml/2006/main"/>
           <a:p xmlns:a="http://schemas.openxmlformats.org/drawingml/2006/main">
             <a:pPr algn="l">
+              <a:buNone/>
               <a:defRPr sz="1050" b="1">
                 <a:solidFill>
                   <a:srgbClr val="064B39"/>
@@ -7476,6 +7580,7 @@
           <a:lstStyle xmlns:a="http://schemas.openxmlformats.org/drawingml/2006/main"/>
           <a:p xmlns:a="http://schemas.openxmlformats.org/drawingml/2006/main">
             <a:pPr algn="l">
+              <a:buNone/>
               <a:defRPr sz="1875" b="1">
                 <a:solidFill>
                   <a:srgbClr val="08110E"/>
@@ -7534,6 +7639,7 @@
           <a:lstStyle xmlns:a="http://schemas.openxmlformats.org/drawingml/2006/main"/>
           <a:p xmlns:a="http://schemas.openxmlformats.org/drawingml/2006/main">
             <a:pPr algn="l">
+              <a:buNone/>
               <a:defRPr sz="1275" b="0">
                 <a:solidFill>
                   <a:srgbClr val="5C6863"/>
@@ -7557,6 +7663,7 @@
           </a:p>
           <a:p xmlns:a="http://schemas.openxmlformats.org/drawingml/2006/main">
             <a:pPr algn="l">
+              <a:buNone/>
               <a:defRPr sz="1275" b="0">
                 <a:solidFill>
                   <a:srgbClr val="5C6863"/>
@@ -7580,6 +7687,7 @@
           </a:p>
           <a:p xmlns:a="http://schemas.openxmlformats.org/drawingml/2006/main">
             <a:pPr algn="l">
+              <a:buNone/>
               <a:defRPr sz="1275" b="0">
                 <a:solidFill>
                   <a:srgbClr val="5C6863"/>
@@ -7673,6 +7781,7 @@
           <a:lstStyle xmlns:a="http://schemas.openxmlformats.org/drawingml/2006/main"/>
           <a:p xmlns:a="http://schemas.openxmlformats.org/drawingml/2006/main">
             <a:pPr algn="ctr">
+              <a:buNone/>
               <a:defRPr sz="975" b="1">
                 <a:solidFill>
                   <a:srgbClr val="FFFFFF"/>
@@ -7731,6 +7840,7 @@
           <a:lstStyle xmlns:a="http://schemas.openxmlformats.org/drawingml/2006/main"/>
           <a:p xmlns:a="http://schemas.openxmlformats.org/drawingml/2006/main">
             <a:pPr algn="l">
+              <a:buNone/>
               <a:defRPr sz="1050" b="1">
                 <a:solidFill>
                   <a:srgbClr val="6D4BC3"/>
@@ -7789,6 +7899,7 @@
           <a:lstStyle xmlns:a="http://schemas.openxmlformats.org/drawingml/2006/main"/>
           <a:p xmlns:a="http://schemas.openxmlformats.org/drawingml/2006/main">
             <a:pPr algn="l">
+              <a:buNone/>
               <a:defRPr sz="1875" b="1">
                 <a:solidFill>
                   <a:srgbClr val="08110E"/>
@@ -7847,6 +7958,7 @@
           <a:lstStyle xmlns:a="http://schemas.openxmlformats.org/drawingml/2006/main"/>
           <a:p xmlns:a="http://schemas.openxmlformats.org/drawingml/2006/main">
             <a:pPr algn="l">
+              <a:buNone/>
               <a:defRPr sz="1275" b="0">
                 <a:solidFill>
                   <a:srgbClr val="5C6863"/>
@@ -7870,6 +7982,7 @@
           </a:p>
           <a:p xmlns:a="http://schemas.openxmlformats.org/drawingml/2006/main">
             <a:pPr algn="l">
+              <a:buNone/>
               <a:defRPr sz="1275" b="0">
                 <a:solidFill>
                   <a:srgbClr val="5C6863"/>
@@ -7893,6 +8006,7 @@
           </a:p>
           <a:p xmlns:a="http://schemas.openxmlformats.org/drawingml/2006/main">
             <a:pPr algn="l">
+              <a:buNone/>
               <a:defRPr sz="1275" b="0">
                 <a:solidFill>
                   <a:srgbClr val="5C6863"/>
@@ -7982,6 +8096,7 @@
           <a:lstStyle xmlns:a="http://schemas.openxmlformats.org/drawingml/2006/main"/>
           <a:p xmlns:a="http://schemas.openxmlformats.org/drawingml/2006/main">
             <a:pPr algn="l">
+              <a:buNone/>
               <a:defRPr sz="1125" b="1">
                 <a:solidFill>
                   <a:srgbClr val="064B39"/>
@@ -8071,6 +8186,7 @@
           <a:lstStyle xmlns:a="http://schemas.openxmlformats.org/drawingml/2006/main"/>
           <a:p xmlns:a="http://schemas.openxmlformats.org/drawingml/2006/main">
             <a:pPr algn="l">
+              <a:buNone/>
               <a:defRPr sz="975" b="1">
                 <a:solidFill>
                   <a:srgbClr val="5C6863"/>
@@ -8158,6 +8274,7 @@
           <a:lstStyle xmlns:a="http://schemas.openxmlformats.org/drawingml/2006/main"/>
           <a:p xmlns:a="http://schemas.openxmlformats.org/drawingml/2006/main">
             <a:pPr algn="l">
+              <a:buNone/>
               <a:defRPr sz="1050" b="1">
                 <a:solidFill>
                   <a:srgbClr val="087A58"/>
@@ -8216,6 +8333,7 @@
           <a:lstStyle xmlns:a="http://schemas.openxmlformats.org/drawingml/2006/main"/>
           <a:p xmlns:a="http://schemas.openxmlformats.org/drawingml/2006/main">
             <a:pPr algn="l">
+              <a:buNone/>
               <a:defRPr sz="3150" b="1">
                 <a:solidFill>
                   <a:srgbClr val="08110E"/>
@@ -8276,14 +8394,14 @@
       </p:sp>
       <p:pic>
         <p:nvPicPr>
-          <p:cNvPr id="23" name=""/>
+          <p:cNvPr id="25" name=""/>
           <p:cNvPicPr>
             <a:picLocks xmlns:a="http://schemas.openxmlformats.org/drawingml/2006/main" noChangeAspect="1"/>
           </p:cNvPicPr>
           <p:nvPr/>
         </p:nvPicPr>
         <p:blipFill>
-          <a:blip xmlns:r="http://schemas.openxmlformats.org/officeDocument/2006/relationships" xmlns:a="http://schemas.openxmlformats.org/drawingml/2006/main" r:embed="R410ac7a6e4414e0f"/>
+          <a:blip xmlns:r="http://schemas.openxmlformats.org/officeDocument/2006/relationships" xmlns:a="http://schemas.openxmlformats.org/drawingml/2006/main" r:embed="R37298a34d456401d"/>
           <a:srcRect xmlns:a="http://schemas.openxmlformats.org/drawingml/2006/main" l="6473" t="0" r="6473" b="0"/>
           <a:stretch xmlns:a="http://schemas.openxmlformats.org/drawingml/2006/main">
             <a:fillRect l="0" t="0" r="0" b="0"/>
@@ -8336,6 +8454,7 @@
           <a:lstStyle xmlns:a="http://schemas.openxmlformats.org/drawingml/2006/main"/>
           <a:p xmlns:a="http://schemas.openxmlformats.org/drawingml/2006/main">
             <a:pPr algn="l">
+              <a:buNone/>
               <a:defRPr sz="1050" b="1">
                 <a:solidFill>
                   <a:srgbClr val="A85B10"/>
@@ -8425,6 +8544,7 @@
           <a:lstStyle xmlns:a="http://schemas.openxmlformats.org/drawingml/2006/main"/>
           <a:p xmlns:a="http://schemas.openxmlformats.org/drawingml/2006/main">
             <a:pPr algn="l">
+              <a:buNone/>
               <a:defRPr sz="1350" b="1">
                 <a:solidFill>
                   <a:srgbClr val="6E3A08"/>
@@ -8483,6 +8603,7 @@
           <a:lstStyle xmlns:a="http://schemas.openxmlformats.org/drawingml/2006/main"/>
           <a:p xmlns:a="http://schemas.openxmlformats.org/drawingml/2006/main">
             <a:pPr algn="l">
+              <a:buNone/>
               <a:defRPr sz="1050" b="1">
                 <a:solidFill>
                   <a:srgbClr val="087A58"/>
@@ -8541,6 +8662,7 @@
           <a:lstStyle xmlns:a="http://schemas.openxmlformats.org/drawingml/2006/main"/>
           <a:p xmlns:a="http://schemas.openxmlformats.org/drawingml/2006/main">
             <a:pPr algn="l">
+              <a:buNone/>
               <a:defRPr sz="1050" b="1">
                 <a:solidFill>
                   <a:srgbClr val="087A58"/>
@@ -8599,6 +8721,7 @@
           <a:lstStyle xmlns:a="http://schemas.openxmlformats.org/drawingml/2006/main"/>
           <a:p xmlns:a="http://schemas.openxmlformats.org/drawingml/2006/main">
             <a:pPr algn="l">
+              <a:buNone/>
               <a:defRPr sz="1275" b="0">
                 <a:solidFill>
                   <a:srgbClr val="08110E"/>
@@ -8657,6 +8780,7 @@
           <a:lstStyle xmlns:a="http://schemas.openxmlformats.org/drawingml/2006/main"/>
           <a:p xmlns:a="http://schemas.openxmlformats.org/drawingml/2006/main">
             <a:pPr algn="l">
+              <a:buNone/>
               <a:defRPr sz="1050" b="1">
                 <a:solidFill>
                   <a:srgbClr val="087A58"/>
@@ -8715,6 +8839,7 @@
           <a:lstStyle xmlns:a="http://schemas.openxmlformats.org/drawingml/2006/main"/>
           <a:p xmlns:a="http://schemas.openxmlformats.org/drawingml/2006/main">
             <a:pPr algn="l">
+              <a:buNone/>
               <a:defRPr sz="1275" b="0">
                 <a:solidFill>
                   <a:srgbClr val="08110E"/>
@@ -8773,6 +8898,7 @@
           <a:lstStyle xmlns:a="http://schemas.openxmlformats.org/drawingml/2006/main"/>
           <a:p xmlns:a="http://schemas.openxmlformats.org/drawingml/2006/main">
             <a:pPr algn="l">
+              <a:buNone/>
               <a:defRPr sz="1050" b="1">
                 <a:solidFill>
                   <a:srgbClr val="087A58"/>
@@ -8831,6 +8957,7 @@
           <a:lstStyle xmlns:a="http://schemas.openxmlformats.org/drawingml/2006/main"/>
           <a:p xmlns:a="http://schemas.openxmlformats.org/drawingml/2006/main">
             <a:pPr algn="l">
+              <a:buNone/>
               <a:defRPr sz="1275" b="0">
                 <a:solidFill>
                   <a:srgbClr val="08110E"/>
@@ -8889,6 +9016,7 @@
           <a:lstStyle xmlns:a="http://schemas.openxmlformats.org/drawingml/2006/main"/>
           <a:p xmlns:a="http://schemas.openxmlformats.org/drawingml/2006/main">
             <a:pPr algn="l">
+              <a:buNone/>
               <a:defRPr sz="1050" b="1">
                 <a:solidFill>
                   <a:srgbClr val="087A58"/>
@@ -8947,6 +9075,7 @@
           <a:lstStyle xmlns:a="http://schemas.openxmlformats.org/drawingml/2006/main"/>
           <a:p xmlns:a="http://schemas.openxmlformats.org/drawingml/2006/main">
             <a:pPr algn="l">
+              <a:buNone/>
               <a:defRPr sz="1275" b="1">
                 <a:solidFill>
                   <a:srgbClr val="08110E"/>
@@ -9005,6 +9134,7 @@
           <a:lstStyle xmlns:a="http://schemas.openxmlformats.org/drawingml/2006/main"/>
           <a:p xmlns:a="http://schemas.openxmlformats.org/drawingml/2006/main">
             <a:pPr algn="l">
+              <a:buNone/>
               <a:defRPr sz="1350" b="1">
                 <a:solidFill>
                   <a:srgbClr val="064B39"/>
@@ -9094,6 +9224,7 @@
           <a:lstStyle xmlns:a="http://schemas.openxmlformats.org/drawingml/2006/main"/>
           <a:p xmlns:a="http://schemas.openxmlformats.org/drawingml/2006/main">
             <a:pPr algn="l">
+              <a:buNone/>
               <a:defRPr sz="975" b="1">
                 <a:solidFill>
                   <a:srgbClr val="5C6863"/>
@@ -9181,6 +9312,7 @@
           <a:lstStyle xmlns:a="http://schemas.openxmlformats.org/drawingml/2006/main"/>
           <a:p xmlns:a="http://schemas.openxmlformats.org/drawingml/2006/main">
             <a:pPr algn="l">
+              <a:buNone/>
               <a:defRPr sz="1050" b="1">
                 <a:solidFill>
                   <a:srgbClr val="087A58"/>
@@ -9239,6 +9371,7 @@
           <a:lstStyle xmlns:a="http://schemas.openxmlformats.org/drawingml/2006/main"/>
           <a:p xmlns:a="http://schemas.openxmlformats.org/drawingml/2006/main">
             <a:pPr algn="l">
+              <a:buNone/>
               <a:defRPr sz="3150" b="1">
                 <a:solidFill>
                   <a:srgbClr val="08110E"/>
@@ -9297,6 +9430,7 @@
           <a:lstStyle xmlns:a="http://schemas.openxmlformats.org/drawingml/2006/main"/>
           <a:p xmlns:a="http://schemas.openxmlformats.org/drawingml/2006/main">
             <a:pPr algn="l">
+              <a:buNone/>
               <a:defRPr sz="4200" b="1">
                 <a:solidFill>
                   <a:srgbClr val="087A58"/>
@@ -9355,6 +9489,7 @@
           <a:lstStyle xmlns:a="http://schemas.openxmlformats.org/drawingml/2006/main"/>
           <a:p xmlns:a="http://schemas.openxmlformats.org/drawingml/2006/main">
             <a:pPr algn="l">
+              <a:buNone/>
               <a:defRPr sz="1350" b="1">
                 <a:solidFill>
                   <a:srgbClr val="08110E"/>
@@ -9413,6 +9548,7 @@
           <a:lstStyle xmlns:a="http://schemas.openxmlformats.org/drawingml/2006/main"/>
           <a:p xmlns:a="http://schemas.openxmlformats.org/drawingml/2006/main">
             <a:pPr algn="l">
+              <a:buNone/>
               <a:defRPr sz="4200" b="1">
                 <a:solidFill>
                   <a:srgbClr val="087A58"/>
@@ -9431,7 +9567,7 @@
                 <a:ea typeface="Helvetica Neue"/>
                 <a:cs typeface="Helvetica Neue"/>
               </a:rPr>
-              <a:t>28</a:t>
+              <a:t>32</a:t>
             </a:r>
           </a:p>
         </p:txBody>
@@ -9471,6 +9607,7 @@
           <a:lstStyle xmlns:a="http://schemas.openxmlformats.org/drawingml/2006/main"/>
           <a:p xmlns:a="http://schemas.openxmlformats.org/drawingml/2006/main">
             <a:pPr algn="l">
+              <a:buNone/>
               <a:defRPr sz="1350" b="1">
                 <a:solidFill>
                   <a:srgbClr val="08110E"/>
@@ -9529,6 +9666,7 @@
           <a:lstStyle xmlns:a="http://schemas.openxmlformats.org/drawingml/2006/main"/>
           <a:p xmlns:a="http://schemas.openxmlformats.org/drawingml/2006/main">
             <a:pPr algn="l">
+              <a:buNone/>
               <a:defRPr sz="4200" b="1">
                 <a:solidFill>
                   <a:srgbClr val="087A58"/>
@@ -9587,6 +9725,7 @@
           <a:lstStyle xmlns:a="http://schemas.openxmlformats.org/drawingml/2006/main"/>
           <a:p xmlns:a="http://schemas.openxmlformats.org/drawingml/2006/main">
             <a:pPr algn="l">
+              <a:buNone/>
               <a:defRPr sz="1350" b="1">
                 <a:solidFill>
                   <a:srgbClr val="08110E"/>
@@ -9645,6 +9784,7 @@
           <a:lstStyle xmlns:a="http://schemas.openxmlformats.org/drawingml/2006/main"/>
           <a:p xmlns:a="http://schemas.openxmlformats.org/drawingml/2006/main">
             <a:pPr algn="l">
+              <a:buNone/>
               <a:defRPr sz="1200" b="0">
                 <a:solidFill>
                   <a:srgbClr val="5C6863"/>
@@ -9738,6 +9878,7 @@
           <a:lstStyle xmlns:a="http://schemas.openxmlformats.org/drawingml/2006/main"/>
           <a:p xmlns:a="http://schemas.openxmlformats.org/drawingml/2006/main">
             <a:pPr algn="l">
+              <a:buNone/>
               <a:defRPr sz="1125" b="1">
                 <a:solidFill>
                   <a:srgbClr val="8BCDB3"/>
@@ -9827,6 +9968,7 @@
           <a:lstStyle xmlns:a="http://schemas.openxmlformats.org/drawingml/2006/main"/>
           <a:p xmlns:a="http://schemas.openxmlformats.org/drawingml/2006/main">
             <a:pPr algn="l">
+              <a:buNone/>
               <a:defRPr sz="1500" b="0">
                 <a:solidFill>
                   <a:srgbClr val="D9F2E8"/>
@@ -9855,6 +9997,7 @@
           </a:p>
           <a:p xmlns:a="http://schemas.openxmlformats.org/drawingml/2006/main">
             <a:pPr algn="l">
+              <a:buNone/>
               <a:defRPr sz="1500" b="0">
                 <a:solidFill>
                   <a:srgbClr val="D9F2E8"/>
@@ -9878,6 +10021,7 @@
           </a:p>
           <a:p xmlns:a="http://schemas.openxmlformats.org/drawingml/2006/main">
             <a:pPr algn="l">
+              <a:buNone/>
               <a:defRPr sz="1500" b="0">
                 <a:solidFill>
                   <a:srgbClr val="D9F2E8"/>
@@ -9901,6 +10045,7 @@
           </a:p>
           <a:p xmlns:a="http://schemas.openxmlformats.org/drawingml/2006/main">
             <a:pPr algn="l">
+              <a:buNone/>
               <a:defRPr sz="1500" b="0">
                 <a:solidFill>
                   <a:srgbClr val="D9F2E8"/>
@@ -9924,6 +10069,7 @@
           </a:p>
           <a:p xmlns:a="http://schemas.openxmlformats.org/drawingml/2006/main">
             <a:pPr algn="l">
+              <a:buNone/>
               <a:defRPr sz="1500" b="0">
                 <a:solidFill>
                   <a:srgbClr val="D9F2E8"/>
@@ -9947,6 +10093,7 @@
           </a:p>
           <a:p xmlns:a="http://schemas.openxmlformats.org/drawingml/2006/main">
             <a:pPr algn="l">
+              <a:buNone/>
               <a:defRPr sz="1500" b="0">
                 <a:solidFill>
                   <a:srgbClr val="D9F2E8"/>
@@ -9970,6 +10117,7 @@
           </a:p>
           <a:p xmlns:a="http://schemas.openxmlformats.org/drawingml/2006/main">
             <a:pPr algn="l">
+              <a:buNone/>
               <a:defRPr sz="1500" b="0">
                 <a:solidFill>
                   <a:srgbClr val="D9F2E8"/>
@@ -9993,6 +10141,7 @@
           </a:p>
           <a:p xmlns:a="http://schemas.openxmlformats.org/drawingml/2006/main">
             <a:pPr algn="l">
+              <a:buNone/>
               <a:defRPr sz="1500" b="0">
                 <a:solidFill>
                   <a:srgbClr val="D9F2E8"/>
@@ -10016,6 +10165,7 @@
           </a:p>
           <a:p xmlns:a="http://schemas.openxmlformats.org/drawingml/2006/main">
             <a:pPr algn="l">
+              <a:buNone/>
               <a:defRPr sz="1500" b="0">
                 <a:solidFill>
                   <a:srgbClr val="D9F2E8"/>
@@ -10039,6 +10189,7 @@
           </a:p>
           <a:p xmlns:a="http://schemas.openxmlformats.org/drawingml/2006/main">
             <a:pPr algn="l">
+              <a:buNone/>
               <a:defRPr sz="1500" b="0">
                 <a:solidFill>
                   <a:srgbClr val="D9F2E8"/>
@@ -10128,6 +10279,7 @@
           <a:lstStyle xmlns:a="http://schemas.openxmlformats.org/drawingml/2006/main"/>
           <a:p xmlns:a="http://schemas.openxmlformats.org/drawingml/2006/main">
             <a:pPr algn="l">
+              <a:buNone/>
               <a:defRPr sz="975" b="1">
                 <a:solidFill>
                   <a:srgbClr val="5C6863"/>
@@ -10215,6 +10367,7 @@
           <a:lstStyle xmlns:a="http://schemas.openxmlformats.org/drawingml/2006/main"/>
           <a:p xmlns:a="http://schemas.openxmlformats.org/drawingml/2006/main">
             <a:pPr algn="l">
+              <a:buNone/>
               <a:defRPr sz="1050" b="1">
                 <a:solidFill>
                   <a:srgbClr val="83E0BB"/>
@@ -10273,6 +10426,7 @@
           <a:lstStyle xmlns:a="http://schemas.openxmlformats.org/drawingml/2006/main"/>
           <a:p xmlns:a="http://schemas.openxmlformats.org/drawingml/2006/main">
             <a:pPr algn="l">
+              <a:buNone/>
               <a:defRPr sz="3600" b="1">
                 <a:solidFill>
                   <a:srgbClr val="FFFFFF"/>
@@ -10331,6 +10485,7 @@
           <a:lstStyle xmlns:a="http://schemas.openxmlformats.org/drawingml/2006/main"/>
           <a:p xmlns:a="http://schemas.openxmlformats.org/drawingml/2006/main">
             <a:pPr algn="l">
+              <a:buNone/>
               <a:defRPr sz="1875" b="0">
                 <a:solidFill>
                   <a:srgbClr val="D8EFE6"/>
@@ -10389,6 +10544,7 @@
           <a:lstStyle xmlns:a="http://schemas.openxmlformats.org/drawingml/2006/main"/>
           <a:p xmlns:a="http://schemas.openxmlformats.org/drawingml/2006/main">
             <a:pPr algn="l">
+              <a:buNone/>
               <a:defRPr sz="1125" b="1">
                 <a:solidFill>
                   <a:srgbClr val="83E0BB"/>
@@ -10447,6 +10603,7 @@
           <a:lstStyle xmlns:a="http://schemas.openxmlformats.org/drawingml/2006/main"/>
           <a:p xmlns:a="http://schemas.openxmlformats.org/drawingml/2006/main">
             <a:pPr algn="l">
+              <a:buNone/>
               <a:defRPr sz="1875" b="1">
                 <a:solidFill>
                   <a:srgbClr val="FFFFFF"/>
@@ -10505,6 +10662,7 @@
           <a:lstStyle xmlns:a="http://schemas.openxmlformats.org/drawingml/2006/main"/>
           <a:p xmlns:a="http://schemas.openxmlformats.org/drawingml/2006/main">
             <a:pPr algn="l">
+              <a:buNone/>
               <a:defRPr sz="1275" b="0">
                 <a:solidFill>
                   <a:srgbClr val="B9D5CA"/>
@@ -10563,6 +10721,7 @@
           <a:lstStyle xmlns:a="http://schemas.openxmlformats.org/drawingml/2006/main"/>
           <a:p xmlns:a="http://schemas.openxmlformats.org/drawingml/2006/main">
             <a:pPr algn="l">
+              <a:buNone/>
               <a:defRPr sz="1125" b="1">
                 <a:solidFill>
                   <a:srgbClr val="83E0BB"/>
@@ -10621,6 +10780,7 @@
           <a:lstStyle xmlns:a="http://schemas.openxmlformats.org/drawingml/2006/main"/>
           <a:p xmlns:a="http://schemas.openxmlformats.org/drawingml/2006/main">
             <a:pPr algn="l">
+              <a:buNone/>
               <a:defRPr sz="1875" b="1">
                 <a:solidFill>
                   <a:srgbClr val="FFFFFF"/>
@@ -10679,6 +10839,7 @@
           <a:lstStyle xmlns:a="http://schemas.openxmlformats.org/drawingml/2006/main"/>
           <a:p xmlns:a="http://schemas.openxmlformats.org/drawingml/2006/main">
             <a:pPr algn="l">
+              <a:buNone/>
               <a:defRPr sz="1275" b="0">
                 <a:solidFill>
                   <a:srgbClr val="B9D5CA"/>
@@ -10737,6 +10898,7 @@
           <a:lstStyle xmlns:a="http://schemas.openxmlformats.org/drawingml/2006/main"/>
           <a:p xmlns:a="http://schemas.openxmlformats.org/drawingml/2006/main">
             <a:pPr algn="l">
+              <a:buNone/>
               <a:defRPr sz="1125" b="1">
                 <a:solidFill>
                   <a:srgbClr val="83E0BB"/>
@@ -10795,6 +10957,7 @@
           <a:lstStyle xmlns:a="http://schemas.openxmlformats.org/drawingml/2006/main"/>
           <a:p xmlns:a="http://schemas.openxmlformats.org/drawingml/2006/main">
             <a:pPr algn="l">
+              <a:buNone/>
               <a:defRPr sz="1875" b="1">
                 <a:solidFill>
                   <a:srgbClr val="FFFFFF"/>
@@ -10853,6 +11016,7 @@
           <a:lstStyle xmlns:a="http://schemas.openxmlformats.org/drawingml/2006/main"/>
           <a:p xmlns:a="http://schemas.openxmlformats.org/drawingml/2006/main">
             <a:pPr algn="l">
+              <a:buNone/>
               <a:defRPr sz="1275" b="0">
                 <a:solidFill>
                   <a:srgbClr val="B9D5CA"/>
@@ -10942,6 +11106,7 @@
           <a:lstStyle xmlns:a="http://schemas.openxmlformats.org/drawingml/2006/main"/>
           <a:p xmlns:a="http://schemas.openxmlformats.org/drawingml/2006/main">
             <a:pPr algn="l">
+              <a:buNone/>
               <a:defRPr sz="1800" b="1">
                 <a:solidFill>
                   <a:srgbClr val="FFFFFF"/>
@@ -11000,6 +11165,7 @@
           <a:lstStyle xmlns:a="http://schemas.openxmlformats.org/drawingml/2006/main"/>
           <a:p xmlns:a="http://schemas.openxmlformats.org/drawingml/2006/main">
             <a:pPr algn="l">
+              <a:buNone/>
               <a:defRPr sz="1200" b="0">
                 <a:solidFill>
                   <a:srgbClr val="83E0BB"/>
@@ -11089,6 +11255,7 @@
           <a:lstStyle xmlns:a="http://schemas.openxmlformats.org/drawingml/2006/main"/>
           <a:p xmlns:a="http://schemas.openxmlformats.org/drawingml/2006/main">
             <a:pPr algn="l">
+              <a:buNone/>
               <a:defRPr sz="975" b="1">
                 <a:solidFill>
                   <a:srgbClr val="B9D5CA"/>

</xml_diff>

<commit_message>
feat: deepen Attestcoin evidence and judge verification
</commit_message>
<xml_diff>
--- a/docs/attestflow-pitch-deck.pptx
+++ b/docs/attestflow-pitch-deck.pptx
@@ -2,21 +2,21 @@
 <file path=ppt/presentation.xml><?xml version="1.0" encoding="utf-8"?>
 <p:presentation xmlns:p="http://schemas.openxmlformats.org/presentationml/2006/main">
   <p:sldMasterIdLst>
-    <p:sldMasterId xmlns:r="http://schemas.openxmlformats.org/officeDocument/2006/relationships" id="2147483648" r:id="R47a7254112214c04"/>
+    <p:sldMasterId xmlns:r="http://schemas.openxmlformats.org/officeDocument/2006/relationships" id="2147483648" r:id="Rf83bff0e6ac14847"/>
   </p:sldMasterIdLst>
   <p:notesMasterIdLst>
-    <p:notesMasterId xmlns:r="http://schemas.openxmlformats.org/officeDocument/2006/relationships" r:id="R3e75bba8eecd4dad"/>
+    <p:notesMasterId xmlns:r="http://schemas.openxmlformats.org/officeDocument/2006/relationships" r:id="R9a14bbc994434ecd"/>
   </p:notesMasterIdLst>
   <p:sldIdLst>
-    <p:sldId xmlns:r="http://schemas.openxmlformats.org/officeDocument/2006/relationships" id="256" r:id="R029b4d68ba164010"/>
-    <p:sldId xmlns:r="http://schemas.openxmlformats.org/officeDocument/2006/relationships" id="257" r:id="R7dad2c87e71a4d57"/>
-    <p:sldId xmlns:r="http://schemas.openxmlformats.org/officeDocument/2006/relationships" id="258" r:id="Rdcca87b9592b4075"/>
-    <p:sldId xmlns:r="http://schemas.openxmlformats.org/officeDocument/2006/relationships" id="259" r:id="R81e78e2656964fd5"/>
-    <p:sldId xmlns:r="http://schemas.openxmlformats.org/officeDocument/2006/relationships" id="260" r:id="Ra17b4aa07f0e4490"/>
-    <p:sldId xmlns:r="http://schemas.openxmlformats.org/officeDocument/2006/relationships" id="261" r:id="R19df5d916fae4f07"/>
-    <p:sldId xmlns:r="http://schemas.openxmlformats.org/officeDocument/2006/relationships" id="262" r:id="R2ad301a739a94004"/>
-    <p:sldId xmlns:r="http://schemas.openxmlformats.org/officeDocument/2006/relationships" id="263" r:id="Rcbe4ea578d73465f"/>
-    <p:sldId xmlns:r="http://schemas.openxmlformats.org/officeDocument/2006/relationships" id="264" r:id="Rc0be3db09b5c4d2b"/>
+    <p:sldId xmlns:r="http://schemas.openxmlformats.org/officeDocument/2006/relationships" id="256" r:id="R9a53b79bfb884f14"/>
+    <p:sldId xmlns:r="http://schemas.openxmlformats.org/officeDocument/2006/relationships" id="257" r:id="R66ec3ae6a0c84301"/>
+    <p:sldId xmlns:r="http://schemas.openxmlformats.org/officeDocument/2006/relationships" id="258" r:id="R4efa32d7c12d4bbc"/>
+    <p:sldId xmlns:r="http://schemas.openxmlformats.org/officeDocument/2006/relationships" id="259" r:id="R48600fc6b9164407"/>
+    <p:sldId xmlns:r="http://schemas.openxmlformats.org/officeDocument/2006/relationships" id="260" r:id="R342b76083e684cea"/>
+    <p:sldId xmlns:r="http://schemas.openxmlformats.org/officeDocument/2006/relationships" id="261" r:id="Rc1fa18c65c524dd9"/>
+    <p:sldId xmlns:r="http://schemas.openxmlformats.org/officeDocument/2006/relationships" id="262" r:id="Rd02593b229e54559"/>
+    <p:sldId xmlns:r="http://schemas.openxmlformats.org/officeDocument/2006/relationships" id="263" r:id="Rc275a141a7b843a8"/>
+    <p:sldId xmlns:r="http://schemas.openxmlformats.org/officeDocument/2006/relationships" id="264" r:id="R47c617cefd764a4a"/>
   </p:sldIdLst>
   <p:sldSz cx="12192000" cy="6858000"/>
   <p:notesSz cx="6858000" cy="9144000"/>
@@ -455,12 +455,22 @@
           </a:p>
           <a:p xmlns:a="http://schemas.openxmlformats.org/drawingml/2006/main">
             <a:r>
+              <a:t>- https://github.com/ximilu0114-droid/ximilu-hackson/blob/main/scripts/judge-verify.mjs</a:t>
+            </a:r>
+          </a:p>
+          <a:p xmlns:a="http://schemas.openxmlformats.org/drawingml/2006/main">
+            <a:r>
               <a:t>- https://github.com/ximilu0114-droid/ximilu-hackson/blob/main/evidence/live-e2e-v2.json</a:t>
             </a:r>
           </a:p>
           <a:p xmlns:a="http://schemas.openxmlformats.org/drawingml/2006/main">
             <a:r>
-              <a:t>- https://github.com/ximilu0114-droid/ximilu-hackson/blob/main/scripts/verify-live-evidence.ts</a:t>
+              <a:t>- https://repo.sourcify.dev/102031/0x4E7410Ebf41C213378E1D8aA4423323303086bF6</a:t>
+            </a:r>
+          </a:p>
+          <a:p xmlns:a="http://schemas.openxmlformats.org/drawingml/2006/main">
+            <a:r>
+              <a:t>- https://repo.sourcify.dev/11155111/0x83A0b8D26Dd28094eE0CA74E57e79028194f868E</a:t>
             </a:r>
           </a:p>
           <a:p xmlns:a="http://schemas.openxmlformats.org/drawingml/2006/main">
@@ -710,7 +720,17 @@
           </a:p>
           <a:p xmlns:a="http://schemas.openxmlformats.org/drawingml/2006/main">
             <a:r>
-              <a:t>- https://github.com/ximilu0114-droid/ximilu-hackson/blob/main/docs/integration.md</a:t>
+              <a:t>- https://github.com/ximilu0114-droid/ximilu-hackson/blob/main/docs/attestcoin-depth.md</a:t>
+            </a:r>
+          </a:p>
+          <a:p xmlns:a="http://schemas.openxmlformats.org/drawingml/2006/main">
+            <a:r>
+              <a:t>- https://github.com/ximilu0114-droid/ximilu-hackson/blob/main/scripts/e2e-batch-proof.ts</a:t>
+            </a:r>
+          </a:p>
+          <a:p xmlns:a="http://schemas.openxmlformats.org/drawingml/2006/main">
+            <a:r>
+              <a:t>- https://github.com/ximilu0114-droid/ximilu-hackson/blob/main/agent/src/prover.ts</a:t>
             </a:r>
           </a:p>
           <a:p xmlns:a="http://schemas.openxmlformats.org/drawingml/2006/main">
@@ -721,11 +741,6 @@
           <a:p xmlns:a="http://schemas.openxmlformats.org/drawingml/2006/main">
             <a:r>
               <a:t>- https://docs.attestcoin.org/attestcoin-protocol/dapp-builder-infrastructure/attestcoin-sdk-usc-sdk</a:t>
-            </a:r>
-          </a:p>
-          <a:p xmlns:a="http://schemas.openxmlformats.org/drawingml/2006/main">
-            <a:r>
-              <a:t>- https://creditcoin-testnet.blockscout.com/tx/0xec29d5b4046d5557c014d6720e6d3799ba0f0b41e31a71147240a09b89c2e4c2</a:t>
             </a:r>
           </a:p>
         </p:txBody>
@@ -1065,12 +1080,22 @@
           </a:p>
           <a:p xmlns:a="http://schemas.openxmlformats.org/drawingml/2006/main">
             <a:r>
+              <a:t>- https://github.com/ximilu0114-droid/ximilu-hackson/blob/main/scripts/judge-verify.mjs</a:t>
+            </a:r>
+          </a:p>
+          <a:p xmlns:a="http://schemas.openxmlformats.org/drawingml/2006/main">
+            <a:r>
               <a:t>- https://github.com/ximilu0114-droid/ximilu-hackson/blob/main/scripts/verify-live-evidence.ts</a:t>
             </a:r>
           </a:p>
           <a:p xmlns:a="http://schemas.openxmlformats.org/drawingml/2006/main">
             <a:r>
-              <a:t>- https://github.com/ximilu0114-droid/ximilu-hackson/blob/main/evidence/live-e2e-v2.json</a:t>
+              <a:t>- https://github.com/ximilu0114-droid/ximilu-hackson/blob/main/scripts/verify-sourcify-v2.mjs</a:t>
+            </a:r>
+          </a:p>
+          <a:p xmlns:a="http://schemas.openxmlformats.org/drawingml/2006/main">
+            <a:r>
+              <a:t>- https://github.com/ximilu0114-droid/ximilu-hackson/blob/main/scripts/e2e-batch-proof.ts</a:t>
             </a:r>
           </a:p>
           <a:p xmlns:a="http://schemas.openxmlformats.org/drawingml/2006/main">
@@ -1081,6 +1106,16 @@
           <a:p xmlns:a="http://schemas.openxmlformats.org/drawingml/2006/main">
             <a:r>
               <a:t>- https://github.com/ximilu0114-droid/ximilu-hackson/blob/main/.github/workflows/codeql.yml</a:t>
+            </a:r>
+          </a:p>
+          <a:p xmlns:a="http://schemas.openxmlformats.org/drawingml/2006/main">
+            <a:r>
+              <a:t>- https://repo.sourcify.dev/102031/0x4E7410Ebf41C213378E1D8aA4423323303086bF6</a:t>
+            </a:r>
+          </a:p>
+          <a:p xmlns:a="http://schemas.openxmlformats.org/drawingml/2006/main">
+            <a:r>
+              <a:t>- https://repo.sourcify.dev/11155111/0x83A0b8D26Dd28094eE0CA74E57e79028194f868E</a:t>
             </a:r>
           </a:p>
         </p:txBody>
@@ -1233,7 +1268,7 @@
   </p:cSld>
   <p:clrMap bg1="lt1" tx1="dk1" bg2="lt2" tx2="dk2" accent1="accent1" accent2="accent2" accent3="accent3" accent4="accent4" accent5="accent5" accent6="accent6" hlink="hlink" folHlink="folHlink"/>
   <p:sldLayoutIdLst>
-    <p:sldLayoutId xmlns:r="http://schemas.openxmlformats.org/officeDocument/2006/relationships" id="2147483649" r:id="R22ef7e7846cb44dd"/>
+    <p:sldLayoutId xmlns:r="http://schemas.openxmlformats.org/officeDocument/2006/relationships" id="2147483649" r:id="R2025326b14694d69"/>
   </p:sldLayoutIdLst>
   <p:txStyles>
     <p:titleStyle>
@@ -2148,29 +2183,7 @@
                 <a:ea typeface="Helvetica Neue"/>
                 <a:cs typeface="Helvetica Neue"/>
               </a:rPr>
-              <a:t>3 linked public-testnet transactions  ·  62 live checks  ·  </a:t>
-            </a:r>
-            <a:r>
-              <a:rPr sz="1200" b="1">
-                <a:solidFill>
-                  <a:srgbClr val="08110E"/>
-                </a:solidFill>
-                <a:latin typeface="Helvetica Neue"/>
-                <a:ea typeface="Helvetica Neue"/>
-                <a:cs typeface="Helvetica Neue"/>
-              </a:rPr>
-              <a:t>32</a:t>
-            </a:r>
-            <a:r>
-              <a:rPr sz="1200" b="1">
-                <a:solidFill>
-                  <a:srgbClr val="08110E"/>
-                </a:solidFill>
-                <a:latin typeface="Helvetica Neue"/>
-                <a:ea typeface="Helvetica Neue"/>
-                <a:cs typeface="Helvetica Neue"/>
-              </a:rPr>
-              <a:t> automated tests</a:t>
+              <a:t>5 gates  ·  62 live checks  ·  32 tests  ·  2 exact matches</a:t>
             </a:r>
           </a:p>
         </p:txBody>
@@ -2219,7 +2232,7 @@
           <p:nvPr/>
         </p:nvPicPr>
         <p:blipFill>
-          <a:blip xmlns:r="http://schemas.openxmlformats.org/officeDocument/2006/relationships" xmlns:a="http://schemas.openxmlformats.org/drawingml/2006/main" r:embed="R7b2683bb15cf44da"/>
+          <a:blip xmlns:r="http://schemas.openxmlformats.org/officeDocument/2006/relationships" xmlns:a="http://schemas.openxmlformats.org/drawingml/2006/main" r:embed="R620fa51ec7454cb3"/>
           <a:srcRect xmlns:a="http://schemas.openxmlformats.org/drawingml/2006/main" l="20871" t="0" r="20871" b="0"/>
           <a:stretch xmlns:a="http://schemas.openxmlformats.org/drawingml/2006/main">
             <a:fillRect l="0" t="0" r="0" b="0"/>
@@ -3490,7 +3503,7 @@
           <p:nvPr/>
         </p:nvPicPr>
         <p:blipFill>
-          <a:blip xmlns:r="http://schemas.openxmlformats.org/officeDocument/2006/relationships" xmlns:a="http://schemas.openxmlformats.org/drawingml/2006/main" r:embed="R4d54f44556f6475d"/>
+          <a:blip xmlns:r="http://schemas.openxmlformats.org/officeDocument/2006/relationships" xmlns:a="http://schemas.openxmlformats.org/drawingml/2006/main" r:embed="R6aa7f654b66e4a0b"/>
           <a:srcRect xmlns:a="http://schemas.openxmlformats.org/drawingml/2006/main" l="0" t="0" r="0" b="0"/>
           <a:stretch xmlns:a="http://schemas.openxmlformats.org/drawingml/2006/main">
             <a:fillRect l="0" t="0" r="0" b="0"/>
@@ -4724,7 +4737,7 @@
           <p:nvPr/>
         </p:nvPicPr>
         <p:blipFill>
-          <a:blip xmlns:r="http://schemas.openxmlformats.org/officeDocument/2006/relationships" xmlns:a="http://schemas.openxmlformats.org/drawingml/2006/main" r:embed="R5ca061f3864148c3"/>
+          <a:blip xmlns:r="http://schemas.openxmlformats.org/officeDocument/2006/relationships" xmlns:a="http://schemas.openxmlformats.org/drawingml/2006/main" r:embed="R3c76fd3fe76443eb"/>
           <a:srcRect xmlns:a="http://schemas.openxmlformats.org/drawingml/2006/main" l="9821" t="0" r="9821" b="0"/>
           <a:stretch xmlns:a="http://schemas.openxmlformats.org/drawingml/2006/main">
             <a:fillRect l="0" t="0" r="0" b="0"/>
@@ -5091,7 +5104,7 @@
                 <a:ea typeface="Helvetica Neue"/>
                 <a:cs typeface="Helvetica Neue"/>
               </a:rPr>
-              <a:t>Builds the real Merkle and continuity proofs.</a:t>
+              <a:t>Builds single and shared multi-block proofs.</a:t>
             </a:r>
           </a:p>
         </p:txBody>
@@ -5268,7 +5281,7 @@
                 <a:ea typeface="Helvetica Neue"/>
                 <a:cs typeface="Helvetica Neue"/>
               </a:rPr>
-              <a:t>verify() synchronously gates CC3 state change.</a:t>
+              <a:t>verify() gates settlement; verifyBatch() gates backlogs.</a:t>
             </a:r>
           </a:p>
         </p:txBody>
@@ -5967,7 +5980,7 @@
           <p:nvPr/>
         </p:nvPicPr>
         <p:blipFill>
-          <a:blip xmlns:r="http://schemas.openxmlformats.org/officeDocument/2006/relationships" xmlns:a="http://schemas.openxmlformats.org/drawingml/2006/main" r:embed="R19fa335a71a74281"/>
+          <a:blip xmlns:r="http://schemas.openxmlformats.org/officeDocument/2006/relationships" xmlns:a="http://schemas.openxmlformats.org/drawingml/2006/main" r:embed="R84ed8ba97e114a14"/>
           <a:srcRect xmlns:a="http://schemas.openxmlformats.org/drawingml/2006/main" l="7485" t="0" r="7485" b="0"/>
           <a:stretch xmlns:a="http://schemas.openxmlformats.org/drawingml/2006/main">
             <a:fillRect l="0" t="0" r="0" b="0"/>
@@ -8401,7 +8414,7 @@
           <p:nvPr/>
         </p:nvPicPr>
         <p:blipFill>
-          <a:blip xmlns:r="http://schemas.openxmlformats.org/officeDocument/2006/relationships" xmlns:a="http://schemas.openxmlformats.org/drawingml/2006/main" r:embed="R37298a34d456401d"/>
+          <a:blip xmlns:r="http://schemas.openxmlformats.org/officeDocument/2006/relationships" xmlns:a="http://schemas.openxmlformats.org/drawingml/2006/main" r:embed="Rd626fae459084e7e"/>
           <a:srcRect xmlns:a="http://schemas.openxmlformats.org/drawingml/2006/main" l="6473" t="0" r="6473" b="0"/>
           <a:stretch xmlns:a="http://schemas.openxmlformats.org/drawingml/2006/main">
             <a:fillRect l="0" t="0" r="0" b="0"/>
@@ -9449,7 +9462,7 @@
                 <a:ea typeface="Helvetica Neue"/>
                 <a:cs typeface="Helvetica Neue"/>
               </a:rPr>
-              <a:t>62</a:t>
+              <a:t>5</a:t>
             </a:r>
           </a:p>
         </p:txBody>
@@ -9508,7 +9521,7 @@
                 <a:ea typeface="Helvetica Neue"/>
                 <a:cs typeface="Helvetica Neue"/>
               </a:rPr>
-              <a:t>live cross-chain checks</a:t>
+              <a:t>independent judge gates</a:t>
             </a:r>
           </a:p>
         </p:txBody>
@@ -9567,7 +9580,7 @@
                 <a:ea typeface="Helvetica Neue"/>
                 <a:cs typeface="Helvetica Neue"/>
               </a:rPr>
-              <a:t>32</a:t>
+              <a:t>62</a:t>
             </a:r>
           </a:p>
         </p:txBody>
@@ -9626,7 +9639,7 @@
                 <a:ea typeface="Helvetica Neue"/>
                 <a:cs typeface="Helvetica Neue"/>
               </a:rPr>
-              <a:t>automated tests</a:t>
+              <a:t>live cross-chain checks</a:t>
             </a:r>
           </a:p>
         </p:txBody>
@@ -9685,7 +9698,7 @@
                 <a:ea typeface="Helvetica Neue"/>
                 <a:cs typeface="Helvetica Neue"/>
               </a:rPr>
-              <a:t>0</a:t>
+              <a:t>2</a:t>
             </a:r>
           </a:p>
         </p:txBody>
@@ -9744,7 +9757,7 @@
                 <a:ea typeface="Helvetica Neue"/>
                 <a:cs typeface="Helvetica Neue"/>
               </a:rPr>
-              <a:t>production vulnerabilities</a:t>
+              <a:t>exact source matches</a:t>
             </a:r>
           </a:p>
         </p:txBody>
@@ -9779,7 +9792,7 @@
         </p:spPr>
         <p:txBody>
           <a:bodyPr xmlns:a="http://schemas.openxmlformats.org/drawingml/2006/main" anchor="t">
-            <a:normAutofit fontScale="76778"/>
+            <a:normAutofit fontScale="90972"/>
           </a:bodyPr>
           <a:lstStyle xmlns:a="http://schemas.openxmlformats.org/drawingml/2006/main"/>
           <a:p xmlns:a="http://schemas.openxmlformats.org/drawingml/2006/main">
@@ -9803,7 +9816,7 @@
                 <a:ea typeface="Helvetica Neue"/>
                 <a:cs typeface="Helvetica Neue"/>
               </a:rPr>
-              <a:t>Network identity · deployment provenance · source status · policy fields · settlement events · both replay guards · payload equality · deployed bytecode equality</a:t>
+              <a:t>32 tests · production build · 0 vulnerabilities · chain evidence · compiler identity · fresh batch + single proofs</a:t>
             </a:r>
           </a:p>
         </p:txBody>
@@ -9897,7 +9910,7 @@
                 <a:ea typeface="Menlo"/>
                 <a:cs typeface="Menlo"/>
               </a:rPr>
-              <a:t>attestflow — public-chain verification</a:t>
+              <a:t>attestflow — five independent gates</a:t>
             </a:r>
           </a:p>
         </p:txBody>
@@ -9987,7 +10000,7 @@
                 <a:ea typeface="Menlo"/>
                 <a:cs typeface="Menlo"/>
               </a:rPr>
-              <a:t>$ npm run verify:evidence</a:t>
+              <a:t>$ npm run judge:verify</a:t>
             </a:r>
           </a:p>
           <a:p xmlns:a="http://schemas.openxmlformats.org/drawingml/2006/main">
@@ -10016,7 +10029,7 @@
                 <a:ea typeface="Menlo"/>
                 <a:cs typeface="Menlo"/>
               </a:rPr>
-              <a:t>{</a:t>
+              <a:t>1/5  CI + 32 tests + build + audit    SUCCESS</a:t>
             </a:r>
           </a:p>
           <a:p xmlns:a="http://schemas.openxmlformats.org/drawingml/2006/main">
@@ -10040,7 +10053,7 @@
                 <a:ea typeface="Menlo"/>
                 <a:cs typeface="Menlo"/>
               </a:rPr>
-              <a:t>  "status": "SUCCESS",</a:t>
+              <a:t>2/5  62 public-chain checks           SUCCESS</a:t>
             </a:r>
           </a:p>
           <a:p xmlns:a="http://schemas.openxmlformats.org/drawingml/2006/main">
@@ -10064,7 +10077,7 @@
                 <a:ea typeface="Menlo"/>
                 <a:cs typeface="Menlo"/>
               </a:rPr>
-              <a:t>  "source": "0x6ac68b…55e7",</a:t>
+              <a:t>3/5  2 Sourcify exact matches         SUCCESS</a:t>
             </a:r>
           </a:p>
           <a:p xmlns:a="http://schemas.openxmlformats.org/drawingml/2006/main">
@@ -10088,7 +10101,7 @@
                 <a:ea typeface="Menlo"/>
                 <a:cs typeface="Menlo"/>
               </a:rPr>
-              <a:t>  "settlement": "0xec29d5…e4c2",</a:t>
+              <a:t>4/5  3-block batch · verifyBatch()    SUCCESS</a:t>
             </a:r>
           </a:p>
           <a:p xmlns:a="http://schemas.openxmlformats.org/drawingml/2006/main">
@@ -10112,7 +10125,7 @@
                 <a:ea typeface="Menlo"/>
                 <a:cs typeface="Menlo"/>
               </a:rPr>
-              <a:t>  "delivery": "0xc692a1…47fb",</a:t>
+              <a:t>5/5  fresh single · verifySingle()    SUCCESS</a:t>
             </a:r>
           </a:p>
           <a:p xmlns:a="http://schemas.openxmlformats.org/drawingml/2006/main">
@@ -10136,7 +10149,7 @@
                 <a:ea typeface="Menlo"/>
                 <a:cs typeface="Menlo"/>
               </a:rPr>
-              <a:t>  "sourceTxId": "0x780a2c…fd1a",</a:t>
+              <a:t/>
             </a:r>
           </a:p>
           <a:p xmlns:a="http://schemas.openxmlformats.org/drawingml/2006/main">
@@ -10160,55 +10173,7 @@
                 <a:ea typeface="Menlo"/>
                 <a:cs typeface="Menlo"/>
               </a:rPr>
-              <a:t>  "payloadHash": "0x4845f5…3faa",</a:t>
-            </a:r>
-          </a:p>
-          <a:p xmlns:a="http://schemas.openxmlformats.org/drawingml/2006/main">
-            <a:pPr algn="l">
-              <a:buNone/>
-              <a:defRPr sz="1500" b="0">
-                <a:solidFill>
-                  <a:srgbClr val="D9F2E8"/>
-                </a:solidFill>
-                <a:latin typeface="Menlo"/>
-                <a:ea typeface="Menlo"/>
-                <a:cs typeface="Menlo"/>
-              </a:defRPr>
-            </a:pPr>
-            <a:r>
-              <a:rPr sz="1500" b="0">
-                <a:solidFill>
-                  <a:srgbClr val="D9F2E8"/>
-                </a:solidFill>
-                <a:latin typeface="Menlo"/>
-                <a:ea typeface="Menlo"/>
-                <a:cs typeface="Menlo"/>
-              </a:rPr>
-              <a:t>  "checks": 62</a:t>
-            </a:r>
-          </a:p>
-          <a:p xmlns:a="http://schemas.openxmlformats.org/drawingml/2006/main">
-            <a:pPr algn="l">
-              <a:buNone/>
-              <a:defRPr sz="1500" b="0">
-                <a:solidFill>
-                  <a:srgbClr val="D9F2E8"/>
-                </a:solidFill>
-                <a:latin typeface="Menlo"/>
-                <a:ea typeface="Menlo"/>
-                <a:cs typeface="Menlo"/>
-              </a:defRPr>
-            </a:pPr>
-            <a:r>
-              <a:rPr sz="1500" b="0">
-                <a:solidFill>
-                  <a:srgbClr val="D9F2E8"/>
-                </a:solidFill>
-                <a:latin typeface="Menlo"/>
-                <a:ea typeface="Menlo"/>
-                <a:cs typeface="Menlo"/>
-              </a:rPr>
-              <a:t>}</a:t>
+              <a:t>{ "status": "SUCCESS" }</a:t>
             </a:r>
           </a:p>
         </p:txBody>

</xml_diff>